<commit_message>
feat: implement racing chart dynamics, cache busting, and smart icons
</commit_message>
<xml_diff>
--- a/GIANT_APRESENTACAO_PREMIUM.pptx
+++ b/GIANT_APRESENTACAO_PREMIUM.pptx
@@ -16,10 +16,6 @@
     <p:sldId id="264" r:id="rId10"/>
     <p:sldId id="265" r:id="rId11"/>
     <p:sldId id="266" r:id="rId12"/>
-    <p:sldId id="267" r:id="rId13"/>
-    <p:sldId id="268" r:id="rId14"/>
-    <p:sldId id="269" r:id="rId15"/>
-    <p:sldId id="270" r:id="rId16"/>
   </p:sldIdLst>
   <p:sldSz cx="9144000" cy="6858000" type="screen4x3"/>
   <p:notesSz cx="6858000" cy="9144000"/>
@@ -3186,7 +3182,7 @@
           <a:noFill/>
         </p:spPr>
         <p:txBody>
-          <a:bodyPr wrap="none">
+          <a:bodyPr wrap="square">
             <a:spAutoFit/>
           </a:bodyPr>
           <a:lstStyle/>
@@ -3197,7 +3193,7 @@
                   <a:srgbClr val="FF2864"/>
                 </a:solidFill>
               </a:rPr>
-              <a:t>Eficiência de Custos em Larga Escala</a:t>
+              <a:t>Mitigação de Riscos &amp; Alucinação (AI Safety)</a:t>
             </a:r>
           </a:p>
         </p:txBody>
@@ -3219,38 +3215,58 @@
           <a:noFill/>
         </p:spPr>
         <p:txBody>
-          <a:bodyPr wrap="none">
+          <a:bodyPr wrap="square">
             <a:spAutoFit/>
           </a:bodyPr>
           <a:lstStyle/>
           <a:p>
-            <a:endParaRPr/>
-          </a:p>
-          <a:p>
-            <a:pPr>
-              <a:defRPr>
-                <a:solidFill>
-                  <a:srgbClr val="22C55E"/>
-                </a:solidFill>
-              </a:defRPr>
-            </a:pPr>
-            <a:r>
-              <a:rPr sz="1800" b="0">
-                <a:solidFill>
-                  <a:srgbClr val="EBEBF5"/>
+            <a:r>
+              <a:rPr>
+                <a:solidFill>
+                  <a:srgbClr val="FFFFFF"/>
                 </a:solidFill>
               </a:rPr>
-              <a:t>Infraestrutura escalável com custo marginal zero.</a:t>
-            </a:r>
-          </a:p>
-          <a:p>
-            <a:r>
-              <a:rPr sz="1800" b="0">
-                <a:solidFill>
-                  <a:srgbClr val="EBEBF5"/>
+              <a:t>• O grande risco corporativo: A maioria das IAs gerativas de vídeo sofre de "Data Hallucination".</a:t>
+            </a:r>
+          </a:p>
+          <a:p>
+            <a:r>
+              <a:rPr>
+                <a:solidFill>
+                  <a:srgbClr val="FFFFFF"/>
                 </a:solidFill>
               </a:rPr>
-              <a:t>Análise cirúrgica &lt; US$ 0,001 (Gemini Flash Pricing).</a:t>
+              <a:t>• Como resolvemos: O vídeo obedece a cálculos nativos determinísticos (Remotion/React).</a:t>
+            </a:r>
+          </a:p>
+          <a:p>
+            <a:r>
+              <a:rPr>
+                <a:solidFill>
+                  <a:srgbClr val="FFFFFF"/>
+                </a:solidFill>
+              </a:rPr>
+              <a:t>• A IA do GiantAnimator atua EXCLUSIVAMENTE como auditora (Fiscal de Pixels), não como geradora de frames.</a:t>
+            </a:r>
+          </a:p>
+          <a:p>
+            <a:r>
+              <a:rPr>
+                <a:solidFill>
+                  <a:srgbClr val="FFFFFF"/>
+                </a:solidFill>
+              </a:rPr>
+              <a:t>• Resiliência de Infraestrutura: Sistema construído com Fallback Loop avançado.</a:t>
+            </a:r>
+          </a:p>
+          <a:p>
+            <a:r>
+              <a:rPr>
+                <a:solidFill>
+                  <a:srgbClr val="FFFFFF"/>
+                </a:solidFill>
+              </a:rPr>
+              <a:t>• Em caso de queda da API de IA, o sistema garante a renderização via algoritmos fallback 100% exatos.</a:t>
             </a:r>
           </a:p>
         </p:txBody>
@@ -3305,7 +3321,7 @@
           <a:noFill/>
         </p:spPr>
         <p:txBody>
-          <a:bodyPr wrap="none">
+          <a:bodyPr wrap="square">
             <a:spAutoFit/>
           </a:bodyPr>
           <a:lstStyle/>
@@ -3316,7 +3332,7 @@
                   <a:srgbClr val="FF2864"/>
                 </a:solidFill>
               </a:rPr>
-              <a:t>Alinhamento Estratégico 2026</a:t>
+              <a:t>GiantAnimator</a:t>
             </a:r>
           </a:p>
         </p:txBody>
@@ -3338,663 +3354,39 @@
           <a:noFill/>
         </p:spPr>
         <p:txBody>
-          <a:bodyPr wrap="none">
-            <a:spAutoFit/>
-          </a:bodyPr>
-          <a:lstStyle/>
-          <a:p>
-            <a:endParaRPr/>
-          </a:p>
-          <a:p>
-            <a:pPr>
-              <a:defRPr>
-                <a:solidFill>
-                  <a:srgbClr val="22C55E"/>
-                </a:solidFill>
-              </a:defRPr>
-            </a:pPr>
-            <a:r>
-              <a:rPr sz="1800" b="0">
-                <a:solidFill>
-                  <a:srgbClr val="EBEBF5"/>
-                </a:solidFill>
-              </a:rPr>
-              <a:t>O Giant materializa a meta de IA com dados íntegros.</a:t>
-            </a:r>
-          </a:p>
-          <a:p>
-            <a:r>
-              <a:rPr sz="1800" b="0">
-                <a:solidFill>
-                  <a:srgbClr val="EBEBF5"/>
-                </a:solidFill>
-              </a:rPr>
-              <a:t>Conteúdo UHD 100% fiel à fonte de dados original.</a:t>
-            </a:r>
-          </a:p>
-        </p:txBody>
-      </p:sp>
-    </p:spTree>
-  </p:cSld>
-  <p:clrMapOvr>
-    <a:masterClrMapping/>
-  </p:clrMapOvr>
-</p:sld>
-</file>
-
-<file path=ppt/slides/slide12.xml><?xml version="1.0" encoding="utf-8"?>
-<p:sld xmlns:a="http://schemas.openxmlformats.org/drawingml/2006/main" xmlns:r="http://schemas.openxmlformats.org/officeDocument/2006/relationships" xmlns:p="http://schemas.openxmlformats.org/presentationml/2006/main">
-  <p:cSld>
-    <p:bg>
-      <p:bgPr>
-        <a:solidFill>
-          <a:srgbClr val="080812"/>
-        </a:solidFill>
-        <a:effectLst/>
-      </p:bgPr>
-    </p:bg>
-    <p:spTree>
-      <p:nvGrpSpPr>
-        <p:cNvPr id="1" name=""/>
-        <p:cNvGrpSpPr/>
-        <p:nvPr/>
-      </p:nvGrpSpPr>
-      <p:grpSpPr>
-        <a:xfrm>
-          <a:off x="0" y="0"/>
-          <a:ext cx="0" cy="0"/>
-          <a:chOff x="0" y="0"/>
-          <a:chExt cx="0" cy="0"/>
-        </a:xfrm>
-      </p:grpSpPr>
-      <p:sp>
-        <p:nvSpPr>
-          <p:cNvPr id="2" name="TextBox 1"/>
-          <p:cNvSpPr txBox="1"/>
-          <p:nvPr/>
-        </p:nvSpPr>
-        <p:spPr>
-          <a:xfrm>
-            <a:off x="457200" y="274320"/>
-            <a:ext cx="8229600" cy="914400"/>
-          </a:xfrm>
-          <a:prstGeom prst="rect">
-            <a:avLst/>
-          </a:prstGeom>
-          <a:noFill/>
-        </p:spPr>
-        <p:txBody>
-          <a:bodyPr wrap="none">
-            <a:spAutoFit/>
-          </a:bodyPr>
-          <a:lstStyle/>
-          <a:p>
-            <a:r>
-              <a:rPr sz="3400" b="1">
-                <a:solidFill>
-                  <a:srgbClr val="FF2864"/>
-                </a:solidFill>
-              </a:rPr>
-              <a:t>Projeção de Mercado (2026 - 2030)</a:t>
-            </a:r>
-          </a:p>
-        </p:txBody>
-      </p:sp>
-      <p:pic>
-        <p:nvPicPr>
-          <p:cNvPr id="3" name="Picture 2" descr="giantanimator_market_future_2030_1776861472552.png"/>
-          <p:cNvPicPr>
-            <a:picLocks noChangeAspect="1"/>
-          </p:cNvPicPr>
-          <p:nvPr/>
-        </p:nvPicPr>
-        <p:blipFill>
-          <a:blip r:embed="rId2"/>
-          <a:stretch>
-            <a:fillRect/>
-          </a:stretch>
-        </p:blipFill>
-        <p:spPr>
-          <a:xfrm>
-            <a:off x="-37414" y="206587"/>
-            <a:ext cx="9218828" cy="6245013"/>
-          </a:xfrm>
-          <a:prstGeom prst="rect">
-            <a:avLst/>
-          </a:prstGeom>
-        </p:spPr>
-      </p:pic>
-    </p:spTree>
-  </p:cSld>
-  <p:clrMapOvr>
-    <a:masterClrMapping/>
-  </p:clrMapOvr>
-</p:sld>
-</file>
-
-<file path=ppt/slides/slide13.xml><?xml version="1.0" encoding="utf-8"?>
-<p:sld xmlns:a="http://schemas.openxmlformats.org/drawingml/2006/main" xmlns:r="http://schemas.openxmlformats.org/officeDocument/2006/relationships" xmlns:p="http://schemas.openxmlformats.org/presentationml/2006/main">
-  <p:cSld>
-    <p:bg>
-      <p:bgPr>
-        <a:solidFill>
-          <a:srgbClr val="080812"/>
-        </a:solidFill>
-        <a:effectLst/>
-      </p:bgPr>
-    </p:bg>
-    <p:spTree>
-      <p:nvGrpSpPr>
-        <p:cNvPr id="1" name=""/>
-        <p:cNvGrpSpPr/>
-        <p:nvPr/>
-      </p:nvGrpSpPr>
-      <p:grpSpPr>
-        <a:xfrm>
-          <a:off x="0" y="0"/>
-          <a:ext cx="0" cy="0"/>
-          <a:chOff x="0" y="0"/>
-          <a:chExt cx="0" cy="0"/>
-        </a:xfrm>
-      </p:grpSpPr>
-      <p:sp>
-        <p:nvSpPr>
-          <p:cNvPr id="2" name="TextBox 1"/>
-          <p:cNvSpPr txBox="1"/>
-          <p:nvPr/>
-        </p:nvSpPr>
-        <p:spPr>
-          <a:xfrm>
-            <a:off x="457200" y="457200"/>
-            <a:ext cx="8229600" cy="914400"/>
-          </a:xfrm>
-          <a:prstGeom prst="rect">
-            <a:avLst/>
-          </a:prstGeom>
-          <a:noFill/>
-        </p:spPr>
-        <p:txBody>
-          <a:bodyPr wrap="none">
-            <a:spAutoFit/>
-          </a:bodyPr>
-          <a:lstStyle/>
-          <a:p>
-            <a:r>
-              <a:rPr sz="3400" b="1">
-                <a:solidFill>
-                  <a:srgbClr val="FF2864"/>
-                </a:solidFill>
-              </a:rPr>
-              <a:t>Integração Nativa: Excel &amp; CSV</a:t>
-            </a:r>
-          </a:p>
-        </p:txBody>
-      </p:sp>
-      <p:sp>
-        <p:nvSpPr>
-          <p:cNvPr id="3" name="TextBox 2"/>
-          <p:cNvSpPr txBox="1"/>
-          <p:nvPr/>
-        </p:nvSpPr>
-        <p:spPr>
-          <a:xfrm>
-            <a:off x="457200" y="1828800"/>
-            <a:ext cx="8077200" cy="2092881"/>
-          </a:xfrm>
-          <a:prstGeom prst="rect">
-            <a:avLst/>
-          </a:prstGeom>
-          <a:noFill/>
-        </p:spPr>
-        <p:txBody>
           <a:bodyPr wrap="square">
             <a:spAutoFit/>
           </a:bodyPr>
           <a:lstStyle/>
           <a:p>
-            <a:endParaRPr dirty="0"/>
-          </a:p>
-          <a:p>
-            <a:r>
-              <a:rPr sz="1800" b="0" dirty="0" err="1">
-                <a:solidFill>
-                  <a:srgbClr val="EBEBF5"/>
+            <a:r>
+              <a:rPr>
+                <a:solidFill>
+                  <a:srgbClr val="FFFFFF"/>
                 </a:solidFill>
               </a:rPr>
-              <a:t>Injeção</a:t>
-            </a:r>
-            <a:r>
-              <a:rPr sz="1800" b="0" dirty="0">
-                <a:solidFill>
-                  <a:srgbClr val="EBEBF5"/>
+              <a:t>A Revolução Autônoma de Dados Visuais.</a:t>
+            </a:r>
+          </a:p>
+          <a:p/>
+          <a:p>
+            <a:r>
+              <a:rPr>
+                <a:solidFill>
+                  <a:srgbClr val="FFFFFF"/>
                 </a:solidFill>
               </a:rPr>
-              <a:t> </a:t>
-            </a:r>
-            <a:r>
-              <a:rPr sz="1800" b="0" dirty="0" err="1">
-                <a:solidFill>
-                  <a:srgbClr val="EBEBF5"/>
+              <a:t>Obrigado.</a:t>
+            </a:r>
+          </a:p>
+          <a:p>
+            <a:r>
+              <a:rPr>
+                <a:solidFill>
+                  <a:srgbClr val="FFFFFF"/>
                 </a:solidFill>
               </a:rPr>
-              <a:t>direta</a:t>
-            </a:r>
-            <a:r>
-              <a:rPr sz="1800" b="0" dirty="0">
-                <a:solidFill>
-                  <a:srgbClr val="EBEBF5"/>
-                </a:solidFill>
-              </a:rPr>
-              <a:t> de </a:t>
-            </a:r>
-            <a:r>
-              <a:rPr sz="1800" b="0" dirty="0" err="1">
-                <a:solidFill>
-                  <a:srgbClr val="EBEBF5"/>
-                </a:solidFill>
-              </a:rPr>
-              <a:t>planilhas</a:t>
-            </a:r>
-            <a:r>
-              <a:rPr sz="1800" b="0" dirty="0">
-                <a:solidFill>
-                  <a:srgbClr val="EBEBF5"/>
-                </a:solidFill>
-              </a:rPr>
-              <a:t> para </a:t>
-            </a:r>
-            <a:r>
-              <a:rPr sz="1800" b="0" dirty="0" err="1">
-                <a:solidFill>
-                  <a:srgbClr val="EBEBF5"/>
-                </a:solidFill>
-              </a:rPr>
-              <a:t>renderização</a:t>
-            </a:r>
-            <a:r>
-              <a:rPr sz="1800" b="0" dirty="0">
-                <a:solidFill>
-                  <a:srgbClr val="EBEBF5"/>
-                </a:solidFill>
-              </a:rPr>
-              <a:t> </a:t>
-            </a:r>
-            <a:r>
-              <a:rPr sz="1800" b="0" dirty="0" err="1">
-                <a:solidFill>
-                  <a:srgbClr val="EBEBF5"/>
-                </a:solidFill>
-              </a:rPr>
-              <a:t>em</a:t>
-            </a:r>
-            <a:r>
-              <a:rPr sz="1800" b="0" dirty="0">
-                <a:solidFill>
-                  <a:srgbClr val="EBEBF5"/>
-                </a:solidFill>
-              </a:rPr>
-              <a:t> </a:t>
-            </a:r>
-            <a:r>
-              <a:rPr sz="1800" b="0" dirty="0" err="1">
-                <a:solidFill>
-                  <a:srgbClr val="EBEBF5"/>
-                </a:solidFill>
-              </a:rPr>
-              <a:t>lote</a:t>
-            </a:r>
-            <a:r>
-              <a:rPr sz="1800" b="0" dirty="0">
-                <a:solidFill>
-                  <a:srgbClr val="EBEBF5"/>
-                </a:solidFill>
-              </a:rPr>
-              <a:t>.</a:t>
-            </a:r>
-          </a:p>
-          <a:p>
-            <a:pPr>
-              <a:defRPr>
-                <a:solidFill>
-                  <a:srgbClr val="22C55E"/>
-                </a:solidFill>
-              </a:defRPr>
-            </a:pPr>
-            <a:r>
-              <a:rPr sz="1800" b="0" dirty="0" err="1">
-                <a:solidFill>
-                  <a:srgbClr val="EBEBF5"/>
-                </a:solidFill>
-              </a:rPr>
-              <a:t>Eliminação</a:t>
-            </a:r>
-            <a:r>
-              <a:rPr sz="1800" b="0" dirty="0">
-                <a:solidFill>
-                  <a:srgbClr val="EBEBF5"/>
-                </a:solidFill>
-              </a:rPr>
-              <a:t> de </a:t>
-            </a:r>
-            <a:r>
-              <a:rPr sz="1800" b="0" dirty="0" err="1">
-                <a:solidFill>
-                  <a:srgbClr val="EBEBF5"/>
-                </a:solidFill>
-              </a:rPr>
-              <a:t>erro</a:t>
-            </a:r>
-            <a:r>
-              <a:rPr sz="1800" b="0" dirty="0">
-                <a:solidFill>
-                  <a:srgbClr val="EBEBF5"/>
-                </a:solidFill>
-              </a:rPr>
-              <a:t> </a:t>
-            </a:r>
-            <a:r>
-              <a:rPr sz="1800" b="0" dirty="0" err="1">
-                <a:solidFill>
-                  <a:srgbClr val="EBEBF5"/>
-                </a:solidFill>
-              </a:rPr>
-              <a:t>humano</a:t>
-            </a:r>
-            <a:r>
-              <a:rPr sz="1800" b="0" dirty="0">
-                <a:solidFill>
-                  <a:srgbClr val="EBEBF5"/>
-                </a:solidFill>
-              </a:rPr>
-              <a:t> no </a:t>
-            </a:r>
-            <a:r>
-              <a:rPr sz="1800" b="0" dirty="0" err="1">
-                <a:solidFill>
-                  <a:srgbClr val="EBEBF5"/>
-                </a:solidFill>
-              </a:rPr>
-              <a:t>preenchimento</a:t>
-            </a:r>
-            <a:r>
-              <a:rPr sz="1800" b="0" dirty="0">
-                <a:solidFill>
-                  <a:srgbClr val="EBEBF5"/>
-                </a:solidFill>
-              </a:rPr>
-              <a:t>.</a:t>
-            </a:r>
-          </a:p>
-          <a:p>
-            <a:r>
-              <a:rPr sz="1800" b="0" dirty="0" err="1">
-                <a:solidFill>
-                  <a:srgbClr val="EBEBF5"/>
-                </a:solidFill>
-              </a:rPr>
-              <a:t>Suporte</a:t>
-            </a:r>
-            <a:r>
-              <a:rPr sz="1800" b="0" dirty="0">
-                <a:solidFill>
-                  <a:srgbClr val="EBEBF5"/>
-                </a:solidFill>
-              </a:rPr>
-              <a:t> a </a:t>
-            </a:r>
-            <a:r>
-              <a:rPr sz="1800" b="0" dirty="0" err="1">
-                <a:solidFill>
-                  <a:srgbClr val="EBEBF5"/>
-                </a:solidFill>
-              </a:rPr>
-              <a:t>estruturas</a:t>
-            </a:r>
-            <a:r>
-              <a:rPr sz="1800" b="0" dirty="0">
-                <a:solidFill>
-                  <a:srgbClr val="EBEBF5"/>
-                </a:solidFill>
-              </a:rPr>
-              <a:t> </a:t>
-            </a:r>
-            <a:r>
-              <a:rPr sz="1800" b="0" dirty="0" err="1">
-                <a:solidFill>
-                  <a:srgbClr val="EBEBF5"/>
-                </a:solidFill>
-              </a:rPr>
-              <a:t>complexas</a:t>
-            </a:r>
-            <a:r>
-              <a:rPr sz="1800" b="0" dirty="0">
-                <a:solidFill>
-                  <a:srgbClr val="EBEBF5"/>
-                </a:solidFill>
-              </a:rPr>
-              <a:t> e </a:t>
-            </a:r>
-            <a:r>
-              <a:rPr sz="1800" b="0" dirty="0" err="1">
-                <a:solidFill>
-                  <a:srgbClr val="EBEBF5"/>
-                </a:solidFill>
-              </a:rPr>
-              <a:t>grandes</a:t>
-            </a:r>
-            <a:r>
-              <a:rPr sz="1800" b="0" dirty="0">
-                <a:solidFill>
-                  <a:srgbClr val="EBEBF5"/>
-                </a:solidFill>
-              </a:rPr>
-              <a:t> volumes de dados.</a:t>
-            </a:r>
-          </a:p>
-        </p:txBody>
-      </p:sp>
-    </p:spTree>
-  </p:cSld>
-  <p:clrMapOvr>
-    <a:masterClrMapping/>
-  </p:clrMapOvr>
-</p:sld>
-</file>
-
-<file path=ppt/slides/slide14.xml><?xml version="1.0" encoding="utf-8"?>
-<p:sld xmlns:a="http://schemas.openxmlformats.org/drawingml/2006/main" xmlns:r="http://schemas.openxmlformats.org/officeDocument/2006/relationships" xmlns:p="http://schemas.openxmlformats.org/presentationml/2006/main">
-  <p:cSld>
-    <p:bg>
-      <p:bgPr>
-        <a:solidFill>
-          <a:srgbClr val="080812"/>
-        </a:solidFill>
-        <a:effectLst/>
-      </p:bgPr>
-    </p:bg>
-    <p:spTree>
-      <p:nvGrpSpPr>
-        <p:cNvPr id="1" name=""/>
-        <p:cNvGrpSpPr/>
-        <p:nvPr/>
-      </p:nvGrpSpPr>
-      <p:grpSpPr>
-        <a:xfrm>
-          <a:off x="0" y="0"/>
-          <a:ext cx="0" cy="0"/>
-          <a:chOff x="0" y="0"/>
-          <a:chExt cx="0" cy="0"/>
-        </a:xfrm>
-      </p:grpSpPr>
-      <p:sp>
-        <p:nvSpPr>
-          <p:cNvPr id="2" name="TextBox 1"/>
-          <p:cNvSpPr txBox="1"/>
-          <p:nvPr/>
-        </p:nvSpPr>
-        <p:spPr>
-          <a:xfrm>
-            <a:off x="457200" y="457200"/>
-            <a:ext cx="8229600" cy="914400"/>
-          </a:xfrm>
-          <a:prstGeom prst="rect">
-            <a:avLst/>
-          </a:prstGeom>
-          <a:noFill/>
-        </p:spPr>
-        <p:txBody>
-          <a:bodyPr wrap="none">
-            <a:spAutoFit/>
-          </a:bodyPr>
-          <a:lstStyle/>
-          <a:p>
-            <a:r>
-              <a:rPr sz="3400" b="1">
-                <a:solidFill>
-                  <a:srgbClr val="FF2864"/>
-                </a:solidFill>
-              </a:rPr>
-              <a:t>Biblioteca de Ativos (Treinados)</a:t>
-            </a:r>
-          </a:p>
-        </p:txBody>
-      </p:sp>
-      <p:sp>
-        <p:nvSpPr>
-          <p:cNvPr id="3" name="TextBox 2"/>
-          <p:cNvSpPr txBox="1"/>
-          <p:nvPr/>
-        </p:nvSpPr>
-        <p:spPr>
-          <a:xfrm>
-            <a:off x="457200" y="1828800"/>
-            <a:ext cx="8229600" cy="4572000"/>
-          </a:xfrm>
-          <a:prstGeom prst="rect">
-            <a:avLst/>
-          </a:prstGeom>
-          <a:noFill/>
-        </p:spPr>
-        <p:txBody>
-          <a:bodyPr wrap="none">
-            <a:spAutoFit/>
-          </a:bodyPr>
-          <a:lstStyle/>
-          <a:p>
-            <a:endParaRPr/>
-          </a:p>
-          <a:p>
-            <a:r>
-              <a:rPr sz="1800" b="0">
-                <a:solidFill>
-                  <a:srgbClr val="EBEBF5"/>
-                </a:solidFill>
-              </a:rPr>
-              <a:t>• Bar, Line, Pie, Horizontal &amp; Comparative Charts</a:t>
-            </a:r>
-          </a:p>
-          <a:p>
-            <a:r>
-              <a:rPr sz="1800" b="0">
-                <a:solidFill>
-                  <a:srgbClr val="EBEBF5"/>
-                </a:solidFill>
-              </a:rPr>
-              <a:t>• Heatmaps, Radar, Funnel &amp; Treemaps</a:t>
-            </a:r>
-          </a:p>
-          <a:p>
-            <a:r>
-              <a:rPr sz="1800" b="0">
-                <a:solidFill>
-                  <a:srgbClr val="EBEBF5"/>
-                </a:solidFill>
-              </a:rPr>
-              <a:t>• Sunburst, Waterfall, Gauge &amp; Gantt Charts</a:t>
-            </a:r>
-          </a:p>
-          <a:p>
-            <a:pPr>
-              <a:defRPr>
-                <a:solidFill>
-                  <a:srgbClr val="22C55E"/>
-                </a:solidFill>
-              </a:defRPr>
-            </a:pPr>
-            <a:r>
-              <a:rPr sz="1800" b="0">
-                <a:solidFill>
-                  <a:srgbClr val="EBEBF5"/>
-                </a:solidFill>
-              </a:rPr>
-              <a:t>Biblioteca em constante expansão (Fidelity Training).</a:t>
-            </a:r>
-          </a:p>
-        </p:txBody>
-      </p:sp>
-    </p:spTree>
-  </p:cSld>
-  <p:clrMapOvr>
-    <a:masterClrMapping/>
-  </p:clrMapOvr>
-</p:sld>
-</file>
-
-<file path=ppt/slides/slide15.xml><?xml version="1.0" encoding="utf-8"?>
-<p:sld xmlns:a="http://schemas.openxmlformats.org/drawingml/2006/main" xmlns:r="http://schemas.openxmlformats.org/officeDocument/2006/relationships" xmlns:p="http://schemas.openxmlformats.org/presentationml/2006/main">
-  <p:cSld>
-    <p:bg>
-      <p:bgPr>
-        <a:solidFill>
-          <a:srgbClr val="080812"/>
-        </a:solidFill>
-        <a:effectLst/>
-      </p:bgPr>
-    </p:bg>
-    <p:spTree>
-      <p:nvGrpSpPr>
-        <p:cNvPr id="1" name=""/>
-        <p:cNvGrpSpPr/>
-        <p:nvPr/>
-      </p:nvGrpSpPr>
-      <p:grpSpPr>
-        <a:xfrm>
-          <a:off x="0" y="0"/>
-          <a:ext cx="0" cy="0"/>
-          <a:chOff x="0" y="0"/>
-          <a:chExt cx="0" cy="0"/>
-        </a:xfrm>
-      </p:grpSpPr>
-      <p:sp>
-        <p:nvSpPr>
-          <p:cNvPr id="2" name="TextBox 1"/>
-          <p:cNvSpPr txBox="1"/>
-          <p:nvPr/>
-        </p:nvSpPr>
-        <p:spPr>
-          <a:xfrm>
-            <a:off x="914400" y="2743200"/>
-            <a:ext cx="7315200" cy="1828800"/>
-          </a:xfrm>
-          <a:prstGeom prst="rect">
-            <a:avLst/>
-          </a:prstGeom>
-          <a:noFill/>
-        </p:spPr>
-        <p:txBody>
-          <a:bodyPr wrap="none">
-            <a:spAutoFit/>
-          </a:bodyPr>
-          <a:lstStyle/>
-          <a:p>
-            <a:pPr algn="ctr"/>
-            <a:r>
-              <a:rPr sz="3400" b="1">
-                <a:solidFill>
-                  <a:srgbClr val="FF2864"/>
-                </a:solidFill>
-              </a:rPr>
-              <a:t>GiantAnimator</a:t>
+              <a:t>2026 © GiantAnimator Systems.</a:t>
             </a:r>
           </a:p>
         </p:txBody>
@@ -4049,7 +3441,7 @@
           <a:noFill/>
         </p:spPr>
         <p:txBody>
-          <a:bodyPr wrap="none">
+          <a:bodyPr wrap="square">
             <a:spAutoFit/>
           </a:bodyPr>
           <a:lstStyle/>
@@ -4060,7 +3452,7 @@
                   <a:srgbClr val="FF2864"/>
                 </a:solidFill>
               </a:rPr>
-              <a:t>Abril 2026: Do Estático ao Autônomo</a:t>
+              <a:t>GiantAnimator: Do Estático ao Autônomo</a:t>
             </a:r>
           </a:p>
         </p:txBody>
@@ -4139,7 +3531,7 @@
           <a:noFill/>
         </p:spPr>
         <p:txBody>
-          <a:bodyPr wrap="none">
+          <a:bodyPr wrap="square">
             <a:spAutoFit/>
           </a:bodyPr>
           <a:lstStyle/>
@@ -4150,7 +3542,7 @@
                   <a:srgbClr val="FF2864"/>
                 </a:solidFill>
               </a:rPr>
-              <a:t>O Desafio: Escala em Tempo Real</a:t>
+              <a:t>O Desafio da Escala vs. Solução Nativa 4K</a:t>
             </a:r>
           </a:p>
         </p:txBody>
@@ -4177,275 +3569,53 @@
           </a:bodyPr>
           <a:lstStyle/>
           <a:p>
-            <a:endParaRPr dirty="0"/>
-          </a:p>
-          <a:p>
-            <a:r>
-              <a:rPr sz="1800" b="0" dirty="0">
-                <a:solidFill>
-                  <a:srgbClr val="EBEBF5"/>
+            <a:r>
+              <a:rPr>
+                <a:solidFill>
+                  <a:srgbClr val="FFFFFF"/>
                 </a:solidFill>
               </a:rPr>
-              <a:t>Volume de dados </a:t>
-            </a:r>
-            <a:r>
-              <a:rPr sz="1800" b="0" dirty="0" err="1">
-                <a:solidFill>
-                  <a:srgbClr val="EBEBF5"/>
+              <a:t>• O volume massivo de dados financeiros em 2026 exige respostas instantâneas.</a:t>
+            </a:r>
+          </a:p>
+          <a:p>
+            <a:r>
+              <a:rPr>
+                <a:solidFill>
+                  <a:srgbClr val="FFFFFF"/>
                 </a:solidFill>
               </a:rPr>
-              <a:t>financeiros</a:t>
-            </a:r>
-            <a:r>
-              <a:rPr sz="1800" b="0" dirty="0">
-                <a:solidFill>
-                  <a:srgbClr val="EBEBF5"/>
+              <a:t>• Relatórios estáticos tradicionais estão obsoletos e não engajam investidores modernos.</a:t>
+            </a:r>
+          </a:p>
+          <a:p>
+            <a:r>
+              <a:rPr>
+                <a:solidFill>
+                  <a:srgbClr val="FFFFFF"/>
                 </a:solidFill>
               </a:rPr>
-              <a:t> </a:t>
-            </a:r>
-            <a:r>
-              <a:rPr sz="1800" b="0" dirty="0" err="1">
-                <a:solidFill>
-                  <a:srgbClr val="EBEBF5"/>
+              <a:t>• Existe um vácuo imenso entre a análise de dados complexa e a comunicação visual.</a:t>
+            </a:r>
+          </a:p>
+          <a:p>
+            <a:r>
+              <a:rPr>
+                <a:solidFill>
+                  <a:srgbClr val="FFFFFF"/>
                 </a:solidFill>
               </a:rPr>
-              <a:t>em</a:t>
-            </a:r>
-            <a:r>
-              <a:rPr sz="1800" b="0" dirty="0">
-                <a:solidFill>
-                  <a:srgbClr val="EBEBF5"/>
+              <a:t>• A Solução: Nosso Motor de vídeo nativo UHD foi construído para os desafios da próxima década.</a:t>
+            </a:r>
+          </a:p>
+          <a:p>
+            <a:r>
+              <a:rPr>
+                <a:solidFill>
+                  <a:srgbClr val="FFFFFF"/>
                 </a:solidFill>
               </a:rPr>
-              <a:t> 2026 </a:t>
-            </a:r>
-            <a:r>
-              <a:rPr sz="1800" b="0" dirty="0" err="1">
-                <a:solidFill>
-                  <a:srgbClr val="EBEBF5"/>
-                </a:solidFill>
-              </a:rPr>
-              <a:t>exige</a:t>
-            </a:r>
-            <a:r>
-              <a:rPr sz="1800" b="0" dirty="0">
-                <a:solidFill>
-                  <a:srgbClr val="EBEBF5"/>
-                </a:solidFill>
-              </a:rPr>
-              <a:t> </a:t>
-            </a:r>
-            <a:r>
-              <a:rPr sz="1800" b="0" dirty="0" err="1">
-                <a:solidFill>
-                  <a:srgbClr val="EBEBF5"/>
-                </a:solidFill>
-              </a:rPr>
-              <a:t>respostas</a:t>
-            </a:r>
-            <a:r>
-              <a:rPr sz="1800" b="0" dirty="0">
-                <a:solidFill>
-                  <a:srgbClr val="EBEBF5"/>
-                </a:solidFill>
-              </a:rPr>
-              <a:t> </a:t>
-            </a:r>
-            <a:r>
-              <a:rPr sz="1800" b="0" dirty="0" err="1">
-                <a:solidFill>
-                  <a:srgbClr val="EBEBF5"/>
-                </a:solidFill>
-              </a:rPr>
-              <a:t>instantâneas</a:t>
-            </a:r>
-            <a:r>
-              <a:rPr sz="1800" b="0" dirty="0">
-                <a:solidFill>
-                  <a:srgbClr val="EBEBF5"/>
-                </a:solidFill>
-              </a:rPr>
-              <a:t>.</a:t>
-            </a:r>
-          </a:p>
-          <a:p>
-            <a:r>
-              <a:rPr sz="1800" b="0" dirty="0" err="1">
-                <a:solidFill>
-                  <a:srgbClr val="EBEBF5"/>
-                </a:solidFill>
-              </a:rPr>
-              <a:t>Relatórios</a:t>
-            </a:r>
-            <a:r>
-              <a:rPr sz="1800" b="0" dirty="0">
-                <a:solidFill>
-                  <a:srgbClr val="EBEBF5"/>
-                </a:solidFill>
-              </a:rPr>
-              <a:t> </a:t>
-            </a:r>
-            <a:r>
-              <a:rPr sz="1800" b="0" dirty="0" err="1">
-                <a:solidFill>
-                  <a:srgbClr val="EBEBF5"/>
-                </a:solidFill>
-              </a:rPr>
-              <a:t>estáticos</a:t>
-            </a:r>
-            <a:r>
-              <a:rPr sz="1800" b="0" dirty="0">
-                <a:solidFill>
-                  <a:srgbClr val="EBEBF5"/>
-                </a:solidFill>
-              </a:rPr>
-              <a:t> </a:t>
-            </a:r>
-            <a:r>
-              <a:rPr sz="1800" b="0" dirty="0" err="1">
-                <a:solidFill>
-                  <a:srgbClr val="EBEBF5"/>
-                </a:solidFill>
-              </a:rPr>
-              <a:t>não</a:t>
-            </a:r>
-            <a:r>
-              <a:rPr sz="1800" b="0" dirty="0">
-                <a:solidFill>
-                  <a:srgbClr val="EBEBF5"/>
-                </a:solidFill>
-              </a:rPr>
-              <a:t> </a:t>
-            </a:r>
-            <a:r>
-              <a:rPr sz="1800" b="0" dirty="0" err="1">
-                <a:solidFill>
-                  <a:srgbClr val="EBEBF5"/>
-                </a:solidFill>
-              </a:rPr>
-              <a:t>atendem</a:t>
-            </a:r>
-            <a:r>
-              <a:rPr sz="1800" b="0" dirty="0">
-                <a:solidFill>
-                  <a:srgbClr val="EBEBF5"/>
-                </a:solidFill>
-              </a:rPr>
-              <a:t> </a:t>
-            </a:r>
-            <a:r>
-              <a:rPr sz="1800" b="0" dirty="0" err="1">
-                <a:solidFill>
-                  <a:srgbClr val="EBEBF5"/>
-                </a:solidFill>
-              </a:rPr>
-              <a:t>mais</a:t>
-            </a:r>
-            <a:r>
-              <a:rPr sz="1800" b="0" dirty="0">
-                <a:solidFill>
-                  <a:srgbClr val="EBEBF5"/>
-                </a:solidFill>
-              </a:rPr>
-              <a:t> o </a:t>
-            </a:r>
-            <a:r>
-              <a:rPr sz="1800" b="0" dirty="0" err="1">
-                <a:solidFill>
-                  <a:srgbClr val="EBEBF5"/>
-                </a:solidFill>
-              </a:rPr>
-              <a:t>dinamismo</a:t>
-            </a:r>
-            <a:r>
-              <a:rPr sz="1800" b="0" dirty="0">
-                <a:solidFill>
-                  <a:srgbClr val="EBEBF5"/>
-                </a:solidFill>
-              </a:rPr>
-              <a:t> do </a:t>
-            </a:r>
-            <a:r>
-              <a:rPr sz="1800" b="0" dirty="0" err="1">
-                <a:solidFill>
-                  <a:srgbClr val="EBEBF5"/>
-                </a:solidFill>
-              </a:rPr>
-              <a:t>mercado</a:t>
-            </a:r>
-            <a:r>
-              <a:rPr sz="1800" b="0" dirty="0">
-                <a:solidFill>
-                  <a:srgbClr val="EBEBF5"/>
-                </a:solidFill>
-              </a:rPr>
-              <a:t>.</a:t>
-            </a:r>
-          </a:p>
-          <a:p>
-            <a:pPr>
-              <a:defRPr>
-                <a:solidFill>
-                  <a:srgbClr val="22C55E"/>
-                </a:solidFill>
-              </a:defRPr>
-            </a:pPr>
-            <a:r>
-              <a:rPr sz="1800" b="0" dirty="0">
-                <a:solidFill>
-                  <a:srgbClr val="EBEBF5"/>
-                </a:solidFill>
-              </a:rPr>
-              <a:t>O </a:t>
-            </a:r>
-            <a:r>
-              <a:rPr sz="1800" b="0" dirty="0" err="1">
-                <a:solidFill>
-                  <a:srgbClr val="EBEBF5"/>
-                </a:solidFill>
-              </a:rPr>
-              <a:t>GiantAnimator</a:t>
-            </a:r>
-            <a:r>
-              <a:rPr sz="1800" b="0" dirty="0">
-                <a:solidFill>
-                  <a:srgbClr val="EBEBF5"/>
-                </a:solidFill>
-              </a:rPr>
-              <a:t> resolve o </a:t>
-            </a:r>
-            <a:r>
-              <a:rPr sz="1800" b="0" dirty="0" err="1">
-                <a:solidFill>
-                  <a:srgbClr val="EBEBF5"/>
-                </a:solidFill>
-              </a:rPr>
-              <a:t>vácuo</a:t>
-            </a:r>
-            <a:r>
-              <a:rPr sz="1800" b="0" dirty="0">
-                <a:solidFill>
-                  <a:srgbClr val="EBEBF5"/>
-                </a:solidFill>
-              </a:rPr>
-              <a:t> entre Dados e </a:t>
-            </a:r>
-            <a:r>
-              <a:rPr sz="1800" b="0" dirty="0" err="1">
-                <a:solidFill>
-                  <a:srgbClr val="EBEBF5"/>
-                </a:solidFill>
-              </a:rPr>
-              <a:t>Comunicação</a:t>
-            </a:r>
-            <a:r>
-              <a:rPr sz="1800" b="0" dirty="0">
-                <a:solidFill>
-                  <a:srgbClr val="EBEBF5"/>
-                </a:solidFill>
-              </a:rPr>
-              <a:t>.</a:t>
+              <a:t>• Resolvemos a latência na geração de vídeos com renderização em tempo real via React/Remotion.</a:t>
             </a:r>
           </a:p>
         </p:txBody>
@@ -4500,66 +3670,18 @@
           <a:noFill/>
         </p:spPr>
         <p:txBody>
-          <a:bodyPr wrap="none">
+          <a:bodyPr wrap="square">
             <a:spAutoFit/>
           </a:bodyPr>
           <a:lstStyle/>
           <a:p>
             <a:r>
-              <a:rPr sz="3400" b="1" dirty="0">
+              <a:rPr sz="3400" b="1">
                 <a:solidFill>
                   <a:srgbClr val="FF2864"/>
                 </a:solidFill>
               </a:rPr>
-              <a:t>A </a:t>
-            </a:r>
-            <a:r>
-              <a:rPr sz="3400" b="1" dirty="0" err="1">
-                <a:solidFill>
-                  <a:srgbClr val="FF2864"/>
-                </a:solidFill>
-              </a:rPr>
-              <a:t>Solução</a:t>
-            </a:r>
-            <a:r>
-              <a:rPr sz="3400" b="1" dirty="0">
-                <a:solidFill>
-                  <a:srgbClr val="FF2864"/>
-                </a:solidFill>
-              </a:rPr>
-              <a:t>: Motor de </a:t>
-            </a:r>
-            <a:r>
-              <a:rPr sz="3400" b="1" dirty="0" err="1">
-                <a:solidFill>
-                  <a:srgbClr val="FF2864"/>
-                </a:solidFill>
-              </a:rPr>
-              <a:t>Vídeo</a:t>
-            </a:r>
-            <a:r>
-              <a:rPr sz="3400" b="1" dirty="0">
-                <a:solidFill>
-                  <a:srgbClr val="FF2864"/>
-                </a:solidFill>
-              </a:rPr>
-              <a:t> </a:t>
-            </a:r>
-            <a:r>
-              <a:rPr sz="3400" b="1" dirty="0" err="1">
-                <a:solidFill>
-                  <a:srgbClr val="FF2864"/>
-                </a:solidFill>
-              </a:rPr>
-              <a:t>Nativo</a:t>
-            </a:r>
-            <a:r>
-              <a:rPr sz="3400" b="1" dirty="0">
-                <a:solidFill>
-                  <a:srgbClr val="FF2864"/>
-                </a:solidFill>
-              </a:rPr>
-              <a:t> 4K</a:t>
+              <a:t>Fluxo Cirúrgico &amp; Silent Auditor Loop</a:t>
             </a:r>
           </a:p>
         </p:txBody>
@@ -4586,153 +3708,53 @@
           </a:bodyPr>
           <a:lstStyle/>
           <a:p>
-            <a:endParaRPr dirty="0"/>
-          </a:p>
-          <a:p>
-            <a:r>
-              <a:rPr sz="1800" b="0" dirty="0">
-                <a:solidFill>
-                  <a:srgbClr val="EBEBF5"/>
+            <a:r>
+              <a:rPr>
+                <a:solidFill>
+                  <a:srgbClr val="FFFFFF"/>
                 </a:solidFill>
               </a:rPr>
-              <a:t>Engine </a:t>
-            </a:r>
-            <a:r>
-              <a:rPr sz="1800" b="0" dirty="0" err="1">
-                <a:solidFill>
-                  <a:srgbClr val="EBEBF5"/>
+              <a:t>• O diferencial absoluto do GiantAnimator é seu "Surgery-Grade Flow" operado por IA de Visão.</a:t>
+            </a:r>
+          </a:p>
+          <a:p>
+            <a:r>
+              <a:rPr>
+                <a:solidFill>
+                  <a:srgbClr val="FFFFFF"/>
                 </a:solidFill>
               </a:rPr>
-              <a:t>construída</a:t>
-            </a:r>
-            <a:r>
-              <a:rPr sz="1800" b="0" dirty="0">
-                <a:solidFill>
-                  <a:srgbClr val="EBEBF5"/>
+              <a:t>• Feedback Loop Autônomo garante 100% de fidelidade nos dados renderizados.</a:t>
+            </a:r>
+          </a:p>
+          <a:p>
+            <a:r>
+              <a:rPr>
+                <a:solidFill>
+                  <a:srgbClr val="FFFFFF"/>
                 </a:solidFill>
               </a:rPr>
-              <a:t> </a:t>
-            </a:r>
-            <a:r>
-              <a:rPr sz="1800" b="0" dirty="0" err="1">
-                <a:solidFill>
-                  <a:srgbClr val="EBEBF5"/>
+              <a:t>• O sistema realiza a auto-correção de eixos e labels em tempo real, sem intervenção humana.</a:t>
+            </a:r>
+          </a:p>
+          <a:p>
+            <a:r>
+              <a:rPr>
+                <a:solidFill>
+                  <a:srgbClr val="FFFFFF"/>
                 </a:solidFill>
               </a:rPr>
-              <a:t>em</a:t>
-            </a:r>
-            <a:r>
-              <a:rPr sz="1800" b="0" dirty="0">
-                <a:solidFill>
-                  <a:srgbClr val="EBEBF5"/>
+              <a:t>• Pipeline resiliente capaz de detectar inconsistências numéricas (clipping, overlap) e corrigi-las.</a:t>
+            </a:r>
+          </a:p>
+          <a:p>
+            <a:r>
+              <a:rPr>
+                <a:solidFill>
+                  <a:srgbClr val="FFFFFF"/>
                 </a:solidFill>
               </a:rPr>
-              <a:t> 2026 para </a:t>
-            </a:r>
-            <a:r>
-              <a:rPr sz="1800" b="0" dirty="0" err="1">
-                <a:solidFill>
-                  <a:srgbClr val="EBEBF5"/>
-                </a:solidFill>
-              </a:rPr>
-              <a:t>os</a:t>
-            </a:r>
-            <a:r>
-              <a:rPr sz="1800" b="0" dirty="0">
-                <a:solidFill>
-                  <a:srgbClr val="EBEBF5"/>
-                </a:solidFill>
-              </a:rPr>
-              <a:t> </a:t>
-            </a:r>
-            <a:r>
-              <a:rPr sz="1800" b="0" dirty="0" err="1">
-                <a:solidFill>
-                  <a:srgbClr val="EBEBF5"/>
-                </a:solidFill>
-              </a:rPr>
-              <a:t>desafios</a:t>
-            </a:r>
-            <a:r>
-              <a:rPr sz="1800" b="0" dirty="0">
-                <a:solidFill>
-                  <a:srgbClr val="EBEBF5"/>
-                </a:solidFill>
-              </a:rPr>
-              <a:t> de 2030.</a:t>
-            </a:r>
-          </a:p>
-          <a:p>
-            <a:pPr>
-              <a:defRPr>
-                <a:solidFill>
-                  <a:srgbClr val="22C55E"/>
-                </a:solidFill>
-              </a:defRPr>
-            </a:pPr>
-            <a:r>
-              <a:rPr sz="1800" b="0" dirty="0" err="1">
-                <a:solidFill>
-                  <a:srgbClr val="EBEBF5"/>
-                </a:solidFill>
-              </a:rPr>
-              <a:t>Análise</a:t>
-            </a:r>
-            <a:r>
-              <a:rPr sz="1800" b="0" dirty="0">
-                <a:solidFill>
-                  <a:srgbClr val="EBEBF5"/>
-                </a:solidFill>
-              </a:rPr>
-              <a:t> de </a:t>
-            </a:r>
-            <a:r>
-              <a:rPr sz="1800" b="0" dirty="0" err="1">
-                <a:solidFill>
-                  <a:srgbClr val="EBEBF5"/>
-                </a:solidFill>
-              </a:rPr>
-              <a:t>Visão</a:t>
-            </a:r>
-            <a:r>
-              <a:rPr sz="1800" b="0" dirty="0">
-                <a:solidFill>
-                  <a:srgbClr val="EBEBF5"/>
-                </a:solidFill>
-              </a:rPr>
-              <a:t> UHD + </a:t>
-            </a:r>
-            <a:r>
-              <a:rPr sz="1800" b="0" dirty="0" err="1">
-                <a:solidFill>
-                  <a:srgbClr val="EBEBF5"/>
-                </a:solidFill>
-              </a:rPr>
-              <a:t>Renderização</a:t>
-            </a:r>
-            <a:r>
-              <a:rPr sz="1800" b="0" dirty="0">
-                <a:solidFill>
-                  <a:srgbClr val="EBEBF5"/>
-                </a:solidFill>
-              </a:rPr>
-              <a:t> </a:t>
-            </a:r>
-            <a:r>
-              <a:rPr sz="1800" b="0" dirty="0" err="1">
-                <a:solidFill>
-                  <a:srgbClr val="EBEBF5"/>
-                </a:solidFill>
-              </a:rPr>
-              <a:t>Remotion</a:t>
-            </a:r>
-            <a:r>
-              <a:rPr sz="1800" b="0" dirty="0">
-                <a:solidFill>
-                  <a:srgbClr val="EBEBF5"/>
-                </a:solidFill>
-              </a:rPr>
-              <a:t>.</a:t>
+              <a:t>• Garantia matemática de que a barra exibida corresponde perfeitamente ao valor numérico exigido.</a:t>
             </a:r>
           </a:p>
         </p:txBody>
@@ -4787,7 +3809,7 @@
           <a:noFill/>
         </p:spPr>
         <p:txBody>
-          <a:bodyPr wrap="none">
+          <a:bodyPr wrap="square">
             <a:spAutoFit/>
           </a:bodyPr>
           <a:lstStyle/>
@@ -4798,7 +3820,7 @@
                   <a:srgbClr val="FF2864"/>
                 </a:solidFill>
               </a:rPr>
-              <a:t>Fluxo Cirúrgico (Surgery-Grade)</a:t>
+              <a:t>Eficiência de Custos em Larga Escala</a:t>
             </a:r>
           </a:p>
         </p:txBody>
@@ -4877,7 +3899,7 @@
           <a:noFill/>
         </p:spPr>
         <p:txBody>
-          <a:bodyPr wrap="none">
+          <a:bodyPr wrap="square">
             <a:spAutoFit/>
           </a:bodyPr>
           <a:lstStyle/>
@@ -4888,7 +3910,7 @@
                   <a:srgbClr val="FF2864"/>
                 </a:solidFill>
               </a:rPr>
-              <a:t>Diferencial: Silent Auditor Loop</a:t>
+              <a:t>Integração Nativa &amp; Biblioteca de Ativos</a:t>
             </a:r>
           </a:p>
         </p:txBody>
@@ -4910,38 +3932,58 @@
           <a:noFill/>
         </p:spPr>
         <p:txBody>
-          <a:bodyPr wrap="none">
+          <a:bodyPr wrap="square">
             <a:spAutoFit/>
           </a:bodyPr>
           <a:lstStyle/>
           <a:p>
-            <a:endParaRPr/>
-          </a:p>
-          <a:p>
-            <a:pPr>
-              <a:defRPr>
-                <a:solidFill>
-                  <a:srgbClr val="22C55E"/>
-                </a:solidFill>
-              </a:defRPr>
-            </a:pPr>
-            <a:r>
-              <a:rPr sz="1800" b="0">
-                <a:solidFill>
-                  <a:srgbClr val="EBEBF5"/>
+            <a:r>
+              <a:rPr>
+                <a:solidFill>
+                  <a:srgbClr val="FFFFFF"/>
                 </a:solidFill>
               </a:rPr>
-              <a:t>Garantia de Fidelidade 100% via Feedback Loop.</a:t>
-            </a:r>
-          </a:p>
-          <a:p>
-            <a:r>
-              <a:rPr sz="1800" b="0">
-                <a:solidFill>
-                  <a:srgbClr val="EBEBF5"/>
+              <a:t>• Injeção direta e transparente de planilhas Excel e arquivos CSV.</a:t>
+            </a:r>
+          </a:p>
+          <a:p>
+            <a:r>
+              <a:rPr>
+                <a:solidFill>
+                  <a:srgbClr val="FFFFFF"/>
                 </a:solidFill>
               </a:rPr>
-              <a:t>Auto-correção de eixos e labels em tempo real.</a:t>
+              <a:t>• O pipeline automatizado mitiga agressivamente falhas de erro humano (o temido "fat-finger").</a:t>
+            </a:r>
+          </a:p>
+          <a:p>
+            <a:r>
+              <a:rPr>
+                <a:solidFill>
+                  <a:srgbClr val="FFFFFF"/>
+                </a:solidFill>
+              </a:rPr>
+              <a:t>• Biblioteca de Ativos Treinados já inclui mais de 20 modelos de gráficos corporativos.</a:t>
+            </a:r>
+          </a:p>
+          <a:p>
+            <a:r>
+              <a:rPr>
+                <a:solidFill>
+                  <a:srgbClr val="FFFFFF"/>
+                </a:solidFill>
+              </a:rPr>
+              <a:t>• Suporte nativo a Waterfall, Heatmaps, Treemaps, Bar, Line, Radar e Gauge Charts.</a:t>
+            </a:r>
+          </a:p>
+          <a:p>
+            <a:r>
+              <a:rPr>
+                <a:solidFill>
+                  <a:srgbClr val="FFFFFF"/>
+                </a:solidFill>
+              </a:rPr>
+              <a:t>• Expansão contínua com estilos visuais hiper-personalizáveis (Theme Intelligence).</a:t>
             </a:r>
           </a:p>
         </p:txBody>
@@ -4996,7 +4038,7 @@
           <a:noFill/>
         </p:spPr>
         <p:txBody>
-          <a:bodyPr wrap="none">
+          <a:bodyPr wrap="square">
             <a:spAutoFit/>
           </a:bodyPr>
           <a:lstStyle/>
@@ -5007,7 +4049,7 @@
                   <a:srgbClr val="FF2864"/>
                 </a:solidFill>
               </a:rPr>
-              <a:t>Vendibilidade: O 'Blue Ocean' do Giant</a:t>
+              <a:t>Potencial de Mercado: O 'Blue Ocean'</a:t>
             </a:r>
           </a:p>
         </p:txBody>
@@ -5029,48 +4071,58 @@
           <a:noFill/>
         </p:spPr>
         <p:txBody>
-          <a:bodyPr wrap="none">
+          <a:bodyPr wrap="square">
             <a:spAutoFit/>
           </a:bodyPr>
           <a:lstStyle/>
           <a:p>
-            <a:endParaRPr/>
-          </a:p>
-          <a:p>
-            <a:r>
-              <a:rPr sz="1800" b="0">
-                <a:solidFill>
-                  <a:srgbClr val="EBEBF5"/>
+            <a:r>
+              <a:rPr>
+                <a:solidFill>
+                  <a:srgbClr val="FFFFFF"/>
                 </a:solidFill>
               </a:rPr>
-              <a:t>RI (Investor Relations): Vídeos de 60s para lucro trimestral.</a:t>
-            </a:r>
-          </a:p>
-          <a:p>
-            <a:r>
-              <a:rPr sz="1800" b="0">
-                <a:solidFill>
-                  <a:srgbClr val="EBEBF5"/>
+              <a:t>• Setor B2B (Investor Relations &amp; Wealth): Vídeos trimestrais automatizados para reporte de lucros.</a:t>
+            </a:r>
+          </a:p>
+          <a:p>
+            <a:r>
+              <a:rPr>
+                <a:solidFill>
+                  <a:srgbClr val="FFFFFF"/>
                 </a:solidFill>
               </a:rPr>
-              <a:t>Wealth Management: Relatórios personalizados para clientes VIP.</a:t>
-            </a:r>
-          </a:p>
-          <a:p>
-            <a:pPr>
-              <a:defRPr>
-                <a:solidFill>
-                  <a:srgbClr val="22C55E"/>
-                </a:solidFill>
-              </a:defRPr>
-            </a:pPr>
-            <a:r>
-              <a:rPr sz="1800" b="0">
-                <a:solidFill>
-                  <a:srgbClr val="EBEBF5"/>
+              <a:t>• Relatórios VIP hiper-personalizados sob demanda para clientes de alta renda (High-Net-Worth).</a:t>
+            </a:r>
+          </a:p>
+          <a:p>
+            <a:r>
+              <a:rPr>
+                <a:solidFill>
+                  <a:srgbClr val="FFFFFF"/>
                 </a:solidFill>
               </a:rPr>
-              <a:t>Marketing de Dados: Posts virais com tendências de mercado.</a:t>
+              <a:t>• SaaS Pro: Assinatura escalável focada em analistas financeiros e criadores de conteúdo de dados.</a:t>
+            </a:r>
+          </a:p>
+          <a:p>
+            <a:r>
+              <a:rPr>
+                <a:solidFill>
+                  <a:srgbClr val="FFFFFF"/>
+                </a:solidFill>
+              </a:rPr>
+              <a:t>• Enterprise Solution: Instalação On-Premise 100% isolada e segura, ideal para Bancos e Corretoras.</a:t>
+            </a:r>
+          </a:p>
+          <a:p>
+            <a:r>
+              <a:rPr>
+                <a:solidFill>
+                  <a:srgbClr val="FFFFFF"/>
+                </a:solidFill>
+              </a:rPr>
+              <a:t>• Um mercado inexplorado que une Data Science puro com Motion Graphics de altíssimo nível.</a:t>
             </a:r>
           </a:p>
         </p:txBody>
@@ -5125,7 +4177,7 @@
           <a:noFill/>
         </p:spPr>
         <p:txBody>
-          <a:bodyPr wrap="none">
+          <a:bodyPr wrap="square">
             <a:spAutoFit/>
           </a:bodyPr>
           <a:lstStyle/>
@@ -5136,7 +4188,7 @@
                   <a:srgbClr val="FF2864"/>
                 </a:solidFill>
               </a:rPr>
-              <a:t>Potencial de Produto (SaaS vs B2B)</a:t>
+              <a:t>Visão de Futuro Estratégica (2026 - 2027)</a:t>
             </a:r>
           </a:p>
         </p:txBody>
@@ -5158,48 +4210,58 @@
           <a:noFill/>
         </p:spPr>
         <p:txBody>
-          <a:bodyPr wrap="none">
+          <a:bodyPr wrap="square">
             <a:spAutoFit/>
           </a:bodyPr>
           <a:lstStyle/>
           <a:p>
-            <a:endParaRPr/>
-          </a:p>
-          <a:p>
-            <a:r>
-              <a:rPr sz="1800" b="0">
-                <a:solidFill>
-                  <a:srgbClr val="EBEBF5"/>
+            <a:r>
+              <a:rPr>
+                <a:solidFill>
+                  <a:srgbClr val="FFFFFF"/>
                 </a:solidFill>
               </a:rPr>
-              <a:t>SaaS Pro: Assinatura para analistas e produtores ($49-$199/mês).</a:t>
-            </a:r>
-          </a:p>
-          <a:p>
-            <a:r>
-              <a:rPr sz="1800" b="0">
-                <a:solidFill>
-                  <a:srgbClr val="EBEBF5"/>
+              <a:t>• Q3/2026: Lançamento oficial da integração de Narração Neural (TTS) hiper-realista.</a:t>
+            </a:r>
+          </a:p>
+          <a:p>
+            <a:r>
+              <a:rPr>
+                <a:solidFill>
+                  <a:srgbClr val="FFFFFF"/>
                 </a:solidFill>
               </a:rPr>
-              <a:t>API de Renderização: Integração com outras plataformas de BI.</a:t>
-            </a:r>
-          </a:p>
-          <a:p>
-            <a:pPr>
-              <a:defRPr>
-                <a:solidFill>
-                  <a:srgbClr val="22C55E"/>
-                </a:solidFill>
-              </a:defRPr>
-            </a:pPr>
-            <a:r>
-              <a:rPr sz="1800" b="0">
-                <a:solidFill>
-                  <a:srgbClr val="EBEBF5"/>
+              <a:t>• Sincronização automática de voz com animações e destaques visuais.</a:t>
+            </a:r>
+          </a:p>
+          <a:p>
+            <a:r>
+              <a:rPr>
+                <a:solidFill>
+                  <a:srgbClr val="FFFFFF"/>
                 </a:solidFill>
               </a:rPr>
-              <a:t>Enterprise Solution: Instalação local/privada para Bancos.</a:t>
+              <a:t>• Q1/2027: Lançamento dos revolucionários "Multi-Agent Reviewers".</a:t>
+            </a:r>
+          </a:p>
+          <a:p>
+            <a:r>
+              <a:rPr>
+                <a:solidFill>
+                  <a:srgbClr val="FFFFFF"/>
+                </a:solidFill>
+              </a:rPr>
+              <a:t>• Implementação de Consenso de Dados Matemáticos Descentralizado para validação de métricas.</a:t>
+            </a:r>
+          </a:p>
+          <a:p>
+            <a:r>
+              <a:rPr>
+                <a:solidFill>
+                  <a:srgbClr val="FFFFFF"/>
+                </a:solidFill>
+              </a:rPr>
+              <a:t>• 2030: Domínio do mercado global de automação de vídeos institucionais baseados em dados.</a:t>
             </a:r>
           </a:p>
         </p:txBody>
@@ -5254,7 +4316,7 @@
           <a:noFill/>
         </p:spPr>
         <p:txBody>
-          <a:bodyPr wrap="none">
+          <a:bodyPr wrap="square">
             <a:spAutoFit/>
           </a:bodyPr>
           <a:lstStyle/>
@@ -5265,7 +4327,7 @@
                   <a:srgbClr val="FF2864"/>
                 </a:solidFill>
               </a:rPr>
-              <a:t>Visão de Futuro (2026 - 2027)</a:t>
+              <a:t>Governança de Dados &amp; Privacidade (Zero-Trust)</a:t>
             </a:r>
           </a:p>
         </p:txBody>
@@ -5287,31 +4349,58 @@
           <a:noFill/>
         </p:spPr>
         <p:txBody>
-          <a:bodyPr wrap="none">
+          <a:bodyPr wrap="square">
             <a:spAutoFit/>
           </a:bodyPr>
           <a:lstStyle/>
           <a:p>
-            <a:endParaRPr/>
-          </a:p>
-          <a:p>
-            <a:r>
-              <a:rPr sz="1800" b="0">
-                <a:solidFill>
-                  <a:srgbClr val="EBEBF5"/>
+            <a:r>
+              <a:rPr>
+                <a:solidFill>
+                  <a:srgbClr val="FFFFFF"/>
                 </a:solidFill>
               </a:rPr>
-              <a:t>Q3/2026: Integração de Narração (TTS) Personalizada.</a:t>
-            </a:r>
-          </a:p>
-          <a:p>
-            <a:r>
-              <a:rPr sz="1800" b="0">
-                <a:solidFill>
-                  <a:srgbClr val="EBEBF5"/>
+              <a:t>• Operação On-Premise / Local: Os datasets confidenciais são processados inteiramente em sandbox local.</a:t>
+            </a:r>
+          </a:p>
+          <a:p>
+            <a:r>
+              <a:rPr>
+                <a:solidFill>
+                  <a:srgbClr val="FFFFFF"/>
                 </a:solidFill>
               </a:rPr>
-              <a:t>Q1/2027: Multi-Agent Reviewers (Consenso de Dados).</a:t>
+              <a:t>• Interação Headless CLI: Arquitetura server-side sem UI web exposta externamente.</a:t>
+            </a:r>
+          </a:p>
+          <a:p>
+            <a:r>
+              <a:rPr>
+                <a:solidFill>
+                  <a:srgbClr val="FFFFFF"/>
+                </a:solidFill>
+              </a:rPr>
+              <a:t>• Mitigação profunda contra riscos de Injeção de Código (SQLi/XSS) e Ataques de DDoS.</a:t>
+            </a:r>
+          </a:p>
+          <a:p>
+            <a:r>
+              <a:rPr>
+                <a:solidFill>
+                  <a:srgbClr val="FFFFFF"/>
+                </a:solidFill>
+              </a:rPr>
+              <a:t>• As chamadas de IA transmitem exclusivamente metadados ou frames ofuscados (pixels sem dados sensíveis).</a:t>
+            </a:r>
+          </a:p>
+          <a:p>
+            <a:r>
+              <a:rPr>
+                <a:solidFill>
+                  <a:srgbClr val="FFFFFF"/>
+                </a:solidFill>
+              </a:rPr>
+              <a:t>• Conformidade rigorosa: Zero tráfego de PII (Personally Identifiable Information) para LLMs externos.</a:t>
             </a:r>
           </a:p>
         </p:txBody>

</xml_diff>